<commit_message>
Add final evaluation results and complete presentation
- Updated presentation.pptx with all confirmed eval results
- Fixed evaluate.py adapter loading bug
- Added .gitignore
- Added Excalidraw diagrams

Co-Authored-By: Claude Sonnet 4.6 <noreply@anthropic.com>
</commit_message>
<xml_diff>
--- a/slides/presentation.pptx
+++ b/slides/presentation.pptx
@@ -5279,7 +5279,7 @@
                 </a:solidFill>
                 <a:latin typeface="Calibri"/>
               </a:rPr>
-              <a:t>0.0%</a:t>
+              <a:t>0.0%*</a:t>
             </a:r>
           </a:p>
         </p:txBody>
@@ -5359,7 +5359,7 @@
                 </a:solidFill>
                 <a:latin typeface="Calibri"/>
               </a:rPr>
-              <a:t>~40</a:t>
+              <a:t>—</a:t>
             </a:r>
           </a:p>
         </p:txBody>
@@ -5439,7 +5439,7 @@
                 </a:solidFill>
                 <a:latin typeface="Calibri"/>
               </a:rPr>
-              <a:t>0.1000</a:t>
+              <a:t>0.1000*</a:t>
             </a:r>
           </a:p>
         </p:txBody>
@@ -5519,7 +5519,7 @@
                 </a:solidFill>
                 <a:latin typeface="Calibri"/>
               </a:rPr>
-              <a:t>~79</a:t>
+              <a:t>—</a:t>
             </a:r>
           </a:p>
         </p:txBody>
@@ -5954,7 +5954,7 @@
                 </a:solidFill>
                 <a:latin typeface="Calibri"/>
               </a:rPr>
-              <a:t>* Triplet model (0.0% ToxiGen) likely collapsed — avg response length 40 words vs base 104 → over-refusal</a:t>
+              <a:t>* Triplet model: loss collapsed to 0.0049 by epoch 2; 0.0% ToxiGen likely over-refusal not genuine detox; RTP 0.1000 worse than base</a:t>
             </a:r>
           </a:p>
         </p:txBody>

</xml_diff>